<commit_message>
docs: regenerate pitch deck with CareCircles peer network and platform updates
</commit_message>
<xml_diff>
--- a/CancerCare360_Pitch_Deck.pptx
+++ b/CancerCare360_Pitch_Deck.pptx
@@ -8120,8 +8120,8 @@
         </p:nvSpPr>
         <p:spPr>
           <a:xfrm>
-            <a:off x="6400800" y="2011680"/>
-            <a:ext cx="4846320" cy="566928"/>
+            <a:off x="6400800" y="1920240"/>
+            <a:ext cx="4846320" cy="530352"/>
           </a:xfrm>
           <a:prstGeom prst="roundRect">
             <a:avLst/>
@@ -8166,8 +8166,8 @@
         </p:nvSpPr>
         <p:spPr>
           <a:xfrm>
-            <a:off x="6537960" y="2066544"/>
-            <a:ext cx="4572000" cy="228600"/>
+            <a:off x="6537960" y="1956816"/>
+            <a:ext cx="4572000" cy="219456"/>
           </a:xfrm>
           <a:prstGeom prst="rect">
             <a:avLst/>
@@ -8184,7 +8184,7 @@
               <a:spcAft>
                 <a:spcPts val="0"/>
               </a:spcAft>
-              <a:defRPr sz="1200" b="1">
+              <a:defRPr sz="1100" b="1">
                 <a:solidFill>
                   <a:srgbClr val="457B9D"/>
                 </a:solidFill>
@@ -8205,7 +8205,7 @@
         </p:nvSpPr>
         <p:spPr>
           <a:xfrm>
-            <a:off x="6537960" y="2286000"/>
+            <a:off x="6537960" y="2157984"/>
             <a:ext cx="4572000" cy="256032"/>
           </a:xfrm>
           <a:prstGeom prst="rect">
@@ -8244,8 +8244,8 @@
         </p:nvSpPr>
         <p:spPr>
           <a:xfrm>
-            <a:off x="6400800" y="2670048"/>
-            <a:ext cx="4846320" cy="566928"/>
+            <a:off x="6400800" y="2523744"/>
+            <a:ext cx="4846320" cy="530352"/>
           </a:xfrm>
           <a:prstGeom prst="roundRect">
             <a:avLst/>
@@ -8290,8 +8290,8 @@
         </p:nvSpPr>
         <p:spPr>
           <a:xfrm>
-            <a:off x="6537960" y="2724912"/>
-            <a:ext cx="4572000" cy="228600"/>
+            <a:off x="6537960" y="2560320"/>
+            <a:ext cx="4572000" cy="219456"/>
           </a:xfrm>
           <a:prstGeom prst="rect">
             <a:avLst/>
@@ -8308,7 +8308,131 @@
               <a:spcAft>
                 <a:spcPts val="0"/>
               </a:spcAft>
-              <a:defRPr sz="1200" b="1">
+              <a:defRPr sz="1100" b="1">
+                <a:solidFill>
+                  <a:srgbClr val="457B9D"/>
+                </a:solidFill>
+                <a:latin typeface="Calibri"/>
+              </a:defRPr>
+            </a:pPr>
+            <a:r>
+              <a:t>CareCircles (Family Connect)</a:t>
+            </a:r>
+          </a:p>
+        </p:txBody>
+      </p:sp>
+      <p:sp>
+        <p:nvSpPr>
+          <p:cNvPr id="75" name="TextBox 74"/>
+          <p:cNvSpPr txBox="1"/>
+          <p:nvPr/>
+        </p:nvSpPr>
+        <p:spPr>
+          <a:xfrm>
+            <a:off x="6537960" y="2761488"/>
+            <a:ext cx="4572000" cy="256032"/>
+          </a:xfrm>
+          <a:prstGeom prst="rect">
+            <a:avLst/>
+          </a:prstGeom>
+          <a:noFill/>
+        </p:spPr>
+        <p:txBody>
+          <a:bodyPr wrap="square">
+            <a:spAutoFit/>
+          </a:bodyPr>
+          <a:lstStyle/>
+          <a:p>
+            <a:pPr algn="l">
+              <a:spcAft>
+                <a:spcPts val="0"/>
+              </a:spcAft>
+              <a:defRPr sz="1000" b="0">
+                <a:solidFill>
+                  <a:srgbClr val="546E7A"/>
+                </a:solidFill>
+                <a:latin typeface="Calibri"/>
+              </a:defRPr>
+            </a:pPr>
+            <a:r>
+              <a:t>Geo &amp; cancer-matched peer network: connects families in Karad/Satara to exchange dysphagia diets &amp; mutual care</a:t>
+            </a:r>
+          </a:p>
+        </p:txBody>
+      </p:sp>
+      <p:sp>
+        <p:nvSpPr>
+          <p:cNvPr id="76" name="Rounded Rectangle 75"/>
+          <p:cNvSpPr/>
+          <p:nvPr/>
+        </p:nvSpPr>
+        <p:spPr>
+          <a:xfrm>
+            <a:off x="6400800" y="3127248"/>
+            <a:ext cx="4846320" cy="530352"/>
+          </a:xfrm>
+          <a:prstGeom prst="roundRect">
+            <a:avLst/>
+          </a:prstGeom>
+          <a:solidFill>
+            <a:srgbClr val="FFFFFF"/>
+          </a:solidFill>
+          <a:ln w="12700">
+            <a:solidFill>
+              <a:srgbClr val="E0E0E0"/>
+            </a:solidFill>
+          </a:ln>
+          <a:effectLst/>
+        </p:spPr>
+        <p:style>
+          <a:lnRef idx="1">
+            <a:schemeClr val="accent1"/>
+          </a:lnRef>
+          <a:fillRef idx="3">
+            <a:schemeClr val="accent1"/>
+          </a:fillRef>
+          <a:effectRef idx="2">
+            <a:schemeClr val="accent1"/>
+          </a:effectRef>
+          <a:fontRef idx="minor">
+            <a:schemeClr val="lt1"/>
+          </a:fontRef>
+        </p:style>
+        <p:txBody>
+          <a:bodyPr rtlCol="0" anchor="ctr"/>
+          <a:lstStyle/>
+          <a:p>
+            <a:pPr algn="ctr"/>
+          </a:p>
+        </p:txBody>
+      </p:sp>
+      <p:sp>
+        <p:nvSpPr>
+          <p:cNvPr id="77" name="TextBox 76"/>
+          <p:cNvSpPr txBox="1"/>
+          <p:nvPr/>
+        </p:nvSpPr>
+        <p:spPr>
+          <a:xfrm>
+            <a:off x="6537960" y="3163824"/>
+            <a:ext cx="4572000" cy="219456"/>
+          </a:xfrm>
+          <a:prstGeom prst="rect">
+            <a:avLst/>
+          </a:prstGeom>
+          <a:noFill/>
+        </p:spPr>
+        <p:txBody>
+          <a:bodyPr wrap="square">
+            <a:spAutoFit/>
+          </a:bodyPr>
+          <a:lstStyle/>
+          <a:p>
+            <a:pPr algn="l">
+              <a:spcAft>
+                <a:spcPts val="0"/>
+              </a:spcAft>
+              <a:defRPr sz="1100" b="1">
                 <a:solidFill>
                   <a:srgbClr val="457B9D"/>
                 </a:solidFill>
@@ -8323,13 +8447,13 @@
       </p:sp>
       <p:sp>
         <p:nvSpPr>
-          <p:cNvPr id="75" name="TextBox 74"/>
+          <p:cNvPr id="78" name="TextBox 77"/>
           <p:cNvSpPr txBox="1"/>
           <p:nvPr/>
         </p:nvSpPr>
         <p:spPr>
           <a:xfrm>
-            <a:off x="6537960" y="2944368"/>
+            <a:off x="6537960" y="3364992"/>
             <a:ext cx="4572000" cy="256032"/>
           </a:xfrm>
           <a:prstGeom prst="rect">
@@ -8362,14 +8486,14 @@
       </p:sp>
       <p:sp>
         <p:nvSpPr>
-          <p:cNvPr id="76" name="Rounded Rectangle 75"/>
-          <p:cNvSpPr/>
-          <p:nvPr/>
-        </p:nvSpPr>
-        <p:spPr>
-          <a:xfrm>
-            <a:off x="6400800" y="3328416"/>
-            <a:ext cx="4846320" cy="566928"/>
+          <p:cNvPr id="79" name="Rounded Rectangle 78"/>
+          <p:cNvSpPr/>
+          <p:nvPr/>
+        </p:nvSpPr>
+        <p:spPr>
+          <a:xfrm>
+            <a:off x="6400800" y="3730752"/>
+            <a:ext cx="4846320" cy="530352"/>
           </a:xfrm>
           <a:prstGeom prst="roundRect">
             <a:avLst/>
@@ -8408,14 +8532,14 @@
       </p:sp>
       <p:sp>
         <p:nvSpPr>
-          <p:cNvPr id="77" name="TextBox 76"/>
+          <p:cNvPr id="80" name="TextBox 79"/>
           <p:cNvSpPr txBox="1"/>
           <p:nvPr/>
         </p:nvSpPr>
         <p:spPr>
           <a:xfrm>
-            <a:off x="6537960" y="3383280"/>
-            <a:ext cx="4572000" cy="228600"/>
+            <a:off x="6537960" y="3767328"/>
+            <a:ext cx="4572000" cy="219456"/>
           </a:xfrm>
           <a:prstGeom prst="rect">
             <a:avLst/>
@@ -8432,7 +8556,7 @@
               <a:spcAft>
                 <a:spcPts val="0"/>
               </a:spcAft>
-              <a:defRPr sz="1200" b="1">
+              <a:defRPr sz="1100" b="1">
                 <a:solidFill>
                   <a:srgbClr val="457B9D"/>
                 </a:solidFill>
@@ -8447,13 +8571,13 @@
       </p:sp>
       <p:sp>
         <p:nvSpPr>
-          <p:cNvPr id="78" name="TextBox 77"/>
+          <p:cNvPr id="81" name="TextBox 80"/>
           <p:cNvSpPr txBox="1"/>
           <p:nvPr/>
         </p:nvSpPr>
         <p:spPr>
           <a:xfrm>
-            <a:off x="6537960" y="3602736"/>
+            <a:off x="6537960" y="3968496"/>
             <a:ext cx="4572000" cy="256032"/>
           </a:xfrm>
           <a:prstGeom prst="rect">
@@ -8486,14 +8610,14 @@
       </p:sp>
       <p:sp>
         <p:nvSpPr>
-          <p:cNvPr id="79" name="Rounded Rectangle 78"/>
-          <p:cNvSpPr/>
-          <p:nvPr/>
-        </p:nvSpPr>
-        <p:spPr>
-          <a:xfrm>
-            <a:off x="6400800" y="3986784"/>
-            <a:ext cx="4846320" cy="566928"/>
+          <p:cNvPr id="82" name="Rounded Rectangle 81"/>
+          <p:cNvSpPr/>
+          <p:nvPr/>
+        </p:nvSpPr>
+        <p:spPr>
+          <a:xfrm>
+            <a:off x="6400800" y="4334256"/>
+            <a:ext cx="4846320" cy="530352"/>
           </a:xfrm>
           <a:prstGeom prst="roundRect">
             <a:avLst/>
@@ -8532,14 +8656,14 @@
       </p:sp>
       <p:sp>
         <p:nvSpPr>
-          <p:cNvPr id="80" name="TextBox 79"/>
+          <p:cNvPr id="83" name="TextBox 82"/>
           <p:cNvSpPr txBox="1"/>
           <p:nvPr/>
         </p:nvSpPr>
         <p:spPr>
           <a:xfrm>
-            <a:off x="6537960" y="4041648"/>
-            <a:ext cx="4572000" cy="228600"/>
+            <a:off x="6537960" y="4370832"/>
+            <a:ext cx="4572000" cy="219456"/>
           </a:xfrm>
           <a:prstGeom prst="rect">
             <a:avLst/>
@@ -8556,7 +8680,7 @@
               <a:spcAft>
                 <a:spcPts val="0"/>
               </a:spcAft>
-              <a:defRPr sz="1200" b="1">
+              <a:defRPr sz="1100" b="1">
                 <a:solidFill>
                   <a:srgbClr val="457B9D"/>
                 </a:solidFill>
@@ -8571,13 +8695,13 @@
       </p:sp>
       <p:sp>
         <p:nvSpPr>
-          <p:cNvPr id="81" name="TextBox 80"/>
+          <p:cNvPr id="84" name="TextBox 83"/>
           <p:cNvSpPr txBox="1"/>
           <p:nvPr/>
         </p:nvSpPr>
         <p:spPr>
           <a:xfrm>
-            <a:off x="6537960" y="4261104"/>
+            <a:off x="6537960" y="4572000"/>
             <a:ext cx="4572000" cy="256032"/>
           </a:xfrm>
           <a:prstGeom prst="rect">
@@ -8610,14 +8734,14 @@
       </p:sp>
       <p:sp>
         <p:nvSpPr>
-          <p:cNvPr id="82" name="Rounded Rectangle 81"/>
-          <p:cNvSpPr/>
-          <p:nvPr/>
-        </p:nvSpPr>
-        <p:spPr>
-          <a:xfrm>
-            <a:off x="6400800" y="4645152"/>
-            <a:ext cx="4846320" cy="566928"/>
+          <p:cNvPr id="85" name="Rounded Rectangle 84"/>
+          <p:cNvSpPr/>
+          <p:nvPr/>
+        </p:nvSpPr>
+        <p:spPr>
+          <a:xfrm>
+            <a:off x="6400800" y="4937760"/>
+            <a:ext cx="4846320" cy="530352"/>
           </a:xfrm>
           <a:prstGeom prst="roundRect">
             <a:avLst/>
@@ -8656,14 +8780,14 @@
       </p:sp>
       <p:sp>
         <p:nvSpPr>
-          <p:cNvPr id="83" name="TextBox 82"/>
+          <p:cNvPr id="86" name="TextBox 85"/>
           <p:cNvSpPr txBox="1"/>
           <p:nvPr/>
         </p:nvSpPr>
         <p:spPr>
           <a:xfrm>
-            <a:off x="6537960" y="4700016"/>
-            <a:ext cx="4572000" cy="228600"/>
+            <a:off x="6537960" y="4974336"/>
+            <a:ext cx="4572000" cy="219456"/>
           </a:xfrm>
           <a:prstGeom prst="rect">
             <a:avLst/>
@@ -8680,7 +8804,7 @@
               <a:spcAft>
                 <a:spcPts val="0"/>
               </a:spcAft>
-              <a:defRPr sz="1200" b="1">
+              <a:defRPr sz="1100" b="1">
                 <a:solidFill>
                   <a:srgbClr val="457B9D"/>
                 </a:solidFill>
@@ -8695,13 +8819,13 @@
       </p:sp>
       <p:sp>
         <p:nvSpPr>
-          <p:cNvPr id="84" name="TextBox 83"/>
+          <p:cNvPr id="87" name="TextBox 86"/>
           <p:cNvSpPr txBox="1"/>
           <p:nvPr/>
         </p:nvSpPr>
         <p:spPr>
           <a:xfrm>
-            <a:off x="6537960" y="4919472"/>
+            <a:off x="6537960" y="5175504"/>
             <a:ext cx="4572000" cy="256032"/>
           </a:xfrm>
           <a:prstGeom prst="rect">
@@ -8734,14 +8858,14 @@
       </p:sp>
       <p:sp>
         <p:nvSpPr>
-          <p:cNvPr id="85" name="Rounded Rectangle 84"/>
-          <p:cNvSpPr/>
-          <p:nvPr/>
-        </p:nvSpPr>
-        <p:spPr>
-          <a:xfrm>
-            <a:off x="6400800" y="5303520"/>
-            <a:ext cx="4846320" cy="566928"/>
+          <p:cNvPr id="88" name="Rounded Rectangle 87"/>
+          <p:cNvSpPr/>
+          <p:nvPr/>
+        </p:nvSpPr>
+        <p:spPr>
+          <a:xfrm>
+            <a:off x="6400800" y="5541264"/>
+            <a:ext cx="4846320" cy="530352"/>
           </a:xfrm>
           <a:prstGeom prst="roundRect">
             <a:avLst/>
@@ -8780,14 +8904,14 @@
       </p:sp>
       <p:sp>
         <p:nvSpPr>
-          <p:cNvPr id="86" name="TextBox 85"/>
+          <p:cNvPr id="89" name="TextBox 88"/>
           <p:cNvSpPr txBox="1"/>
           <p:nvPr/>
         </p:nvSpPr>
         <p:spPr>
           <a:xfrm>
-            <a:off x="6537960" y="5358384"/>
-            <a:ext cx="4572000" cy="228600"/>
+            <a:off x="6537960" y="5577840"/>
+            <a:ext cx="4572000" cy="219456"/>
           </a:xfrm>
           <a:prstGeom prst="rect">
             <a:avLst/>
@@ -8804,7 +8928,7 @@
               <a:spcAft>
                 <a:spcPts val="0"/>
               </a:spcAft>
-              <a:defRPr sz="1200" b="1">
+              <a:defRPr sz="1100" b="1">
                 <a:solidFill>
                   <a:srgbClr val="457B9D"/>
                 </a:solidFill>
@@ -8819,13 +8943,13 @@
       </p:sp>
       <p:sp>
         <p:nvSpPr>
-          <p:cNvPr id="87" name="TextBox 86"/>
+          <p:cNvPr id="90" name="TextBox 89"/>
           <p:cNvSpPr txBox="1"/>
           <p:nvPr/>
         </p:nvSpPr>
         <p:spPr>
           <a:xfrm>
-            <a:off x="6537960" y="5577840"/>
+            <a:off x="6537960" y="5779008"/>
             <a:ext cx="4572000" cy="256032"/>
           </a:xfrm>
           <a:prstGeom prst="rect">

</xml_diff>

<commit_message>
docs: regenerate pitch deck with CareRelief financial aid and trust funds navigator
</commit_message>
<xml_diff>
--- a/CancerCare360_Pitch_Deck.pptx
+++ b/CancerCare360_Pitch_Deck.pptx
@@ -8355,7 +8355,7 @@
               </a:defRPr>
             </a:pPr>
             <a:r>
-              <a:t>Geo &amp; cancer-matched peer network: connects families in Karad/Satara to exchange dysphagia diets &amp; mutual care</a:t>
+              <a:t>Geo &amp; cancer-matched peer network: connects families in Karad/Satara to exchange dysphagia diets &amp; care</a:t>
             </a:r>
           </a:p>
         </p:txBody>
@@ -8440,7 +8440,7 @@
               </a:defRPr>
             </a:pPr>
             <a:r>
-              <a:t>My Appointments</a:t>
+              <a:t>CareRelief (Aid &amp; Grants)</a:t>
             </a:r>
           </a:p>
         </p:txBody>
@@ -8479,7 +8479,7 @@
               </a:defRPr>
             </a:pPr>
             <a:r>
-              <a:t>View upcoming appointments, request new bookings, reschedule inquiries</a:t>
+              <a:t>CMRF, PMNRF, Lalbaugcha Raja, Siddhivinayak, MJPJAY grants &amp; 1-click Treatment Cost Dossier</a:t>
             </a:r>
           </a:p>
         </p:txBody>
@@ -8539,6 +8539,130 @@
         <p:spPr>
           <a:xfrm>
             <a:off x="6537960" y="3767328"/>
+            <a:ext cx="4572000" cy="219456"/>
+          </a:xfrm>
+          <a:prstGeom prst="rect">
+            <a:avLst/>
+          </a:prstGeom>
+          <a:noFill/>
+        </p:spPr>
+        <p:txBody>
+          <a:bodyPr wrap="square">
+            <a:spAutoFit/>
+          </a:bodyPr>
+          <a:lstStyle/>
+          <a:p>
+            <a:pPr algn="l">
+              <a:spcAft>
+                <a:spcPts val="0"/>
+              </a:spcAft>
+              <a:defRPr sz="1100" b="1">
+                <a:solidFill>
+                  <a:srgbClr val="457B9D"/>
+                </a:solidFill>
+                <a:latin typeface="Calibri"/>
+              </a:defRPr>
+            </a:pPr>
+            <a:r>
+              <a:t>My Appointments &amp; Flow</a:t>
+            </a:r>
+          </a:p>
+        </p:txBody>
+      </p:sp>
+      <p:sp>
+        <p:nvSpPr>
+          <p:cNvPr id="81" name="TextBox 80"/>
+          <p:cNvSpPr txBox="1"/>
+          <p:nvPr/>
+        </p:nvSpPr>
+        <p:spPr>
+          <a:xfrm>
+            <a:off x="6537960" y="3968496"/>
+            <a:ext cx="4572000" cy="256032"/>
+          </a:xfrm>
+          <a:prstGeom prst="rect">
+            <a:avLst/>
+          </a:prstGeom>
+          <a:noFill/>
+        </p:spPr>
+        <p:txBody>
+          <a:bodyPr wrap="square">
+            <a:spAutoFit/>
+          </a:bodyPr>
+          <a:lstStyle/>
+          <a:p>
+            <a:pPr algn="l">
+              <a:spcAft>
+                <a:spcPts val="0"/>
+              </a:spcAft>
+              <a:defRPr sz="1000" b="0">
+                <a:solidFill>
+                  <a:srgbClr val="546E7A"/>
+                </a:solidFill>
+                <a:latin typeface="Calibri"/>
+              </a:defRPr>
+            </a:pPr>
+            <a:r>
+              <a:t>View upcoming appointments, request new bookings, reschedule inquiries with care coordinators</a:t>
+            </a:r>
+          </a:p>
+        </p:txBody>
+      </p:sp>
+      <p:sp>
+        <p:nvSpPr>
+          <p:cNvPr id="82" name="Rounded Rectangle 81"/>
+          <p:cNvSpPr/>
+          <p:nvPr/>
+        </p:nvSpPr>
+        <p:spPr>
+          <a:xfrm>
+            <a:off x="6400800" y="4334256"/>
+            <a:ext cx="4846320" cy="530352"/>
+          </a:xfrm>
+          <a:prstGeom prst="roundRect">
+            <a:avLst/>
+          </a:prstGeom>
+          <a:solidFill>
+            <a:srgbClr val="FFFFFF"/>
+          </a:solidFill>
+          <a:ln w="12700">
+            <a:solidFill>
+              <a:srgbClr val="E0E0E0"/>
+            </a:solidFill>
+          </a:ln>
+          <a:effectLst/>
+        </p:spPr>
+        <p:style>
+          <a:lnRef idx="1">
+            <a:schemeClr val="accent1"/>
+          </a:lnRef>
+          <a:fillRef idx="3">
+            <a:schemeClr val="accent1"/>
+          </a:fillRef>
+          <a:effectRef idx="2">
+            <a:schemeClr val="accent1"/>
+          </a:effectRef>
+          <a:fontRef idx="minor">
+            <a:schemeClr val="lt1"/>
+          </a:fontRef>
+        </p:style>
+        <p:txBody>
+          <a:bodyPr rtlCol="0" anchor="ctr"/>
+          <a:lstStyle/>
+          <a:p>
+            <a:pPr algn="ctr"/>
+          </a:p>
+        </p:txBody>
+      </p:sp>
+      <p:sp>
+        <p:nvSpPr>
+          <p:cNvPr id="83" name="TextBox 82"/>
+          <p:cNvSpPr txBox="1"/>
+          <p:nvPr/>
+        </p:nvSpPr>
+        <p:spPr>
+          <a:xfrm>
+            <a:off x="6537960" y="4370832"/>
             <a:ext cx="4572000" cy="219456"/>
           </a:xfrm>
           <a:prstGeom prst="rect">
@@ -8571,13 +8695,13 @@
       </p:sp>
       <p:sp>
         <p:nvSpPr>
-          <p:cNvPr id="81" name="TextBox 80"/>
+          <p:cNvPr id="84" name="TextBox 83"/>
           <p:cNvSpPr txBox="1"/>
           <p:nvPr/>
         </p:nvSpPr>
         <p:spPr>
           <a:xfrm>
-            <a:off x="6537960" y="3968496"/>
+            <a:off x="6537960" y="4572000"/>
             <a:ext cx="4572000" cy="256032"/>
           </a:xfrm>
           <a:prstGeom prst="rect">
@@ -8603,20 +8727,20 @@
               </a:defRPr>
             </a:pPr>
             <a:r>
-              <a:t>Simplified visual journey timeline (Completed / In Progress / Upcoming)</a:t>
+              <a:t>Visual journey timeline (Completed / In Progress / Upcoming chemo and radiation milestones)</a:t>
             </a:r>
           </a:p>
         </p:txBody>
       </p:sp>
       <p:sp>
         <p:nvSpPr>
-          <p:cNvPr id="82" name="Rounded Rectangle 81"/>
-          <p:cNvSpPr/>
-          <p:nvPr/>
-        </p:nvSpPr>
-        <p:spPr>
-          <a:xfrm>
-            <a:off x="6400800" y="4334256"/>
+          <p:cNvPr id="85" name="Rounded Rectangle 84"/>
+          <p:cNvSpPr/>
+          <p:nvPr/>
+        </p:nvSpPr>
+        <p:spPr>
+          <a:xfrm>
+            <a:off x="6400800" y="4937760"/>
             <a:ext cx="4846320" cy="530352"/>
           </a:xfrm>
           <a:prstGeom prst="roundRect">
@@ -8656,13 +8780,13 @@
       </p:sp>
       <p:sp>
         <p:nvSpPr>
-          <p:cNvPr id="83" name="TextBox 82"/>
+          <p:cNvPr id="86" name="TextBox 85"/>
           <p:cNvSpPr txBox="1"/>
           <p:nvPr/>
         </p:nvSpPr>
         <p:spPr>
           <a:xfrm>
-            <a:off x="6537960" y="4370832"/>
+            <a:off x="6537960" y="4974336"/>
             <a:ext cx="4572000" cy="219456"/>
           </a:xfrm>
           <a:prstGeom prst="rect">
@@ -8695,13 +8819,13 @@
       </p:sp>
       <p:sp>
         <p:nvSpPr>
-          <p:cNvPr id="84" name="TextBox 83"/>
+          <p:cNvPr id="87" name="TextBox 86"/>
           <p:cNvSpPr txBox="1"/>
           <p:nvPr/>
         </p:nvSpPr>
         <p:spPr>
           <a:xfrm>
-            <a:off x="6537960" y="4572000"/>
+            <a:off x="6537960" y="5175504"/>
             <a:ext cx="4572000" cy="256032"/>
           </a:xfrm>
           <a:prstGeom prst="rect">
@@ -8727,20 +8851,20 @@
               </a:defRPr>
             </a:pPr>
             <a:r>
-              <a:t>Secure digital medical records locker with clinician-verified downloads</a:t>
+              <a:t>Secure digital medical records locker with clinician-verified downloads and ABHA sync</a:t>
             </a:r>
           </a:p>
         </p:txBody>
       </p:sp>
       <p:sp>
         <p:nvSpPr>
-          <p:cNvPr id="85" name="Rounded Rectangle 84"/>
-          <p:cNvSpPr/>
-          <p:nvPr/>
-        </p:nvSpPr>
-        <p:spPr>
-          <a:xfrm>
-            <a:off x="6400800" y="4937760"/>
+          <p:cNvPr id="88" name="Rounded Rectangle 87"/>
+          <p:cNvSpPr/>
+          <p:nvPr/>
+        </p:nvSpPr>
+        <p:spPr>
+          <a:xfrm>
+            <a:off x="6400800" y="5541264"/>
             <a:ext cx="4846320" cy="530352"/>
           </a:xfrm>
           <a:prstGeom prst="roundRect">
@@ -8780,13 +8904,13 @@
       </p:sp>
       <p:sp>
         <p:nvSpPr>
-          <p:cNvPr id="86" name="TextBox 85"/>
+          <p:cNvPr id="89" name="TextBox 88"/>
           <p:cNvSpPr txBox="1"/>
           <p:nvPr/>
         </p:nvSpPr>
         <p:spPr>
           <a:xfrm>
-            <a:off x="6537960" y="4974336"/>
+            <a:off x="6537960" y="5577840"/>
             <a:ext cx="4572000" cy="219456"/>
           </a:xfrm>
           <a:prstGeom prst="rect">
@@ -8812,20 +8936,20 @@
               </a:defRPr>
             </a:pPr>
             <a:r>
-              <a:t>Patient Education</a:t>
+              <a:t>Patient Guides &amp; Education</a:t>
             </a:r>
           </a:p>
         </p:txBody>
       </p:sp>
       <p:sp>
         <p:nvSpPr>
-          <p:cNvPr id="87" name="TextBox 86"/>
+          <p:cNvPr id="90" name="TextBox 89"/>
           <p:cNvSpPr txBox="1"/>
           <p:nvPr/>
         </p:nvSpPr>
         <p:spPr>
           <a:xfrm>
-            <a:off x="6537960" y="5175504"/>
+            <a:off x="6537960" y="5779008"/>
             <a:ext cx="4572000" cy="256032"/>
           </a:xfrm>
           <a:prstGeom prst="rect">
@@ -8851,131 +8975,7 @@
               </a:defRPr>
             </a:pPr>
             <a:r>
-              <a:t>Multi-lingual library (English, Hindi, Marathi): nutrition, side effects, financial guidance</a:t>
-            </a:r>
-          </a:p>
-        </p:txBody>
-      </p:sp>
-      <p:sp>
-        <p:nvSpPr>
-          <p:cNvPr id="88" name="Rounded Rectangle 87"/>
-          <p:cNvSpPr/>
-          <p:nvPr/>
-        </p:nvSpPr>
-        <p:spPr>
-          <a:xfrm>
-            <a:off x="6400800" y="5541264"/>
-            <a:ext cx="4846320" cy="530352"/>
-          </a:xfrm>
-          <a:prstGeom prst="roundRect">
-            <a:avLst/>
-          </a:prstGeom>
-          <a:solidFill>
-            <a:srgbClr val="FFFFFF"/>
-          </a:solidFill>
-          <a:ln w="12700">
-            <a:solidFill>
-              <a:srgbClr val="E0E0E0"/>
-            </a:solidFill>
-          </a:ln>
-          <a:effectLst/>
-        </p:spPr>
-        <p:style>
-          <a:lnRef idx="1">
-            <a:schemeClr val="accent1"/>
-          </a:lnRef>
-          <a:fillRef idx="3">
-            <a:schemeClr val="accent1"/>
-          </a:fillRef>
-          <a:effectRef idx="2">
-            <a:schemeClr val="accent1"/>
-          </a:effectRef>
-          <a:fontRef idx="minor">
-            <a:schemeClr val="lt1"/>
-          </a:fontRef>
-        </p:style>
-        <p:txBody>
-          <a:bodyPr rtlCol="0" anchor="ctr"/>
-          <a:lstStyle/>
-          <a:p>
-            <a:pPr algn="ctr"/>
-          </a:p>
-        </p:txBody>
-      </p:sp>
-      <p:sp>
-        <p:nvSpPr>
-          <p:cNvPr id="89" name="TextBox 88"/>
-          <p:cNvSpPr txBox="1"/>
-          <p:nvPr/>
-        </p:nvSpPr>
-        <p:spPr>
-          <a:xfrm>
-            <a:off x="6537960" y="5577840"/>
-            <a:ext cx="4572000" cy="219456"/>
-          </a:xfrm>
-          <a:prstGeom prst="rect">
-            <a:avLst/>
-          </a:prstGeom>
-          <a:noFill/>
-        </p:spPr>
-        <p:txBody>
-          <a:bodyPr wrap="square">
-            <a:spAutoFit/>
-          </a:bodyPr>
-          <a:lstStyle/>
-          <a:p>
-            <a:pPr algn="l">
-              <a:spcAft>
-                <a:spcPts val="0"/>
-              </a:spcAft>
-              <a:defRPr sz="1100" b="1">
-                <a:solidFill>
-                  <a:srgbClr val="457B9D"/>
-                </a:solidFill>
-                <a:latin typeface="Calibri"/>
-              </a:defRPr>
-            </a:pPr>
-            <a:r>
-              <a:t>Settings &amp; Privacy</a:t>
-            </a:r>
-          </a:p>
-        </p:txBody>
-      </p:sp>
-      <p:sp>
-        <p:nvSpPr>
-          <p:cNvPr id="90" name="TextBox 89"/>
-          <p:cNvSpPr txBox="1"/>
-          <p:nvPr/>
-        </p:nvSpPr>
-        <p:spPr>
-          <a:xfrm>
-            <a:off x="6537960" y="5779008"/>
-            <a:ext cx="4572000" cy="256032"/>
-          </a:xfrm>
-          <a:prstGeom prst="rect">
-            <a:avLst/>
-          </a:prstGeom>
-          <a:noFill/>
-        </p:spPr>
-        <p:txBody>
-          <a:bodyPr wrap="square">
-            <a:spAutoFit/>
-          </a:bodyPr>
-          <a:lstStyle/>
-          <a:p>
-            <a:pPr algn="l">
-              <a:spcAft>
-                <a:spcPts val="0"/>
-              </a:spcAft>
-              <a:defRPr sz="1000" b="0">
-                <a:solidFill>
-                  <a:srgbClr val="546E7A"/>
-                </a:solidFill>
-                <a:latin typeface="Calibri"/>
-              </a:defRPr>
-            </a:pPr>
-            <a:r>
-              <a:t>DPDP Act 2023 compliant: notification preferences, ABHA ID, consent revocation</a:t>
+              <a:t>Multi-lingual library (English, Hindi, Marathi): nutrition, chemo side effects, financial rights</a:t>
             </a:r>
           </a:p>
         </p:txBody>
@@ -15052,7 +15052,7 @@
               </a:defRPr>
             </a:pPr>
             <a:r>
-              <a:t>32</a:t>
+              <a:t>34</a:t>
             </a:r>
           </a:p>
         </p:txBody>
@@ -15130,7 +15130,7 @@
               </a:defRPr>
             </a:pPr>
             <a:r>
-              <a:t>41</a:t>
+              <a:t>51</a:t>
             </a:r>
           </a:p>
         </p:txBody>
@@ -15208,7 +15208,7 @@
               </a:defRPr>
             </a:pPr>
             <a:r>
-              <a:t>22+</a:t>
+              <a:t>25+</a:t>
             </a:r>
           </a:p>
         </p:txBody>
@@ -15286,7 +15286,7 @@
               </a:defRPr>
             </a:pPr>
             <a:r>
-              <a:t>6</a:t>
+              <a:t>8</a:t>
             </a:r>
           </a:p>
         </p:txBody>
@@ -15442,7 +15442,7 @@
               </a:defRPr>
             </a:pPr>
             <a:r>
-              <a:t>10+</a:t>
+              <a:t>12+</a:t>
             </a:r>
           </a:p>
         </p:txBody>
@@ -15481,7 +15481,7 @@
               </a:defRPr>
             </a:pPr>
             <a:r>
-              <a:t>Investigation Modalities</a:t>
+              <a:t>Govt &amp; Trust Funds</a:t>
             </a:r>
           </a:p>
         </p:txBody>

</xml_diff>